<commit_message>
replace the notion of "copy & swap" by "transmit & swap"
</commit_message>
<xml_diff>
--- a/VEEPortingGuide/images/ui_overview2.pptx
+++ b/VEEPortingGuide/images/ui_overview2.pptx
@@ -9650,7 +9650,7 @@
               <a:rPr lang="fr-FR" smtClean="0">
                 <a:latin typeface="Calibri Regular" charset="0"/>
               </a:rPr>
-              <a:t>vendredi 23 février 2024</a:t>
+              <a:t>lundi 18 mars 2024</a:t>
             </a:fld>
             <a:endParaRPr lang="en-US" dirty="0">
               <a:latin typeface="Calibri Regular" charset="0"/>
@@ -9828,7 +9828,7 @@
           <a:p>
             <a:fld id="{885721CF-495B-2B41-A23A-4D3221F80235}" type="datetime2">
               <a:rPr lang="fr-FR" smtClean="0"/>
-              <a:t>vendredi 23 février 2024</a:t>
+              <a:t>lundi 18 mars 2024</a:t>
             </a:fld>
             <a:endParaRPr lang="en-US" dirty="0"/>
           </a:p>
@@ -24092,7 +24092,7 @@
           <a:p>
             <a:fld id="{4E285625-C24A-4341-90BC-6CD71F835625}" type="datetimeFigureOut">
               <a:rPr lang="en-GB" smtClean="0"/>
-              <a:t>23/02/2024</a:t>
+              <a:t>18/03/2024</a:t>
             </a:fld>
             <a:endParaRPr lang="en-GB"/>
           </a:p>
@@ -36093,7 +36093,7 @@
                 <a:latin typeface="Source Sans Pro Light" panose="020B0403030403020204" pitchFamily="34" charset="77"/>
                 <a:ea typeface="Source Sans Pro" panose="020B0503030403020204" pitchFamily="34" charset="0"/>
               </a:rPr>
-              <a:t>Copy &amp; Swap</a:t>
+              <a:t>Transmit &amp; Swap</a:t>
             </a:r>
           </a:p>
         </p:txBody>
@@ -38366,7 +38366,7 @@
                 <a:latin typeface="Source Sans Pro Light" panose="020B0403030403020204" pitchFamily="34" charset="77"/>
                 <a:ea typeface="Source Sans Pro" panose="020B0503030403020204" pitchFamily="34" charset="0"/>
               </a:rPr>
-              <a:t>Copy &amp; Swap</a:t>
+              <a:t>Transmit &amp; Swap</a:t>
             </a:r>
           </a:p>
         </p:txBody>
@@ -40892,7 +40892,7 @@
                 <a:latin typeface="Source Sans Pro Light" panose="020B0403030403020204" pitchFamily="34" charset="77"/>
                 <a:ea typeface="Source Sans Pro" panose="020B0503030403020204" pitchFamily="34" charset="0"/>
               </a:rPr>
-              <a:t>Copy &amp; Swap</a:t>
+              <a:t>Transmit &amp; Swap</a:t>
             </a:r>
           </a:p>
         </p:txBody>
@@ -41511,14 +41511,24 @@
           <a:p>
             <a:pPr algn="ctr"/>
             <a:r>
-              <a:rPr lang="en-US" sz="2000" b="1" dirty="0">
+              <a:rPr lang="en-US" sz="2000" b="1">
                 <a:solidFill>
                   <a:schemeClr val="tx2"/>
                 </a:solidFill>
                 <a:latin typeface="Source Sans Pro Light" panose="020B0403030403020204" pitchFamily="34" charset="77"/>
                 <a:ea typeface="Source Sans Pro" panose="020B0503030403020204" pitchFamily="34" charset="0"/>
               </a:rPr>
-              <a:t>Copy &amp; Swap</a:t>
+              <a:t>Transmit </a:t>
+            </a:r>
+            <a:r>
+              <a:rPr lang="en-US" sz="2000" b="1" dirty="0">
+                <a:solidFill>
+                  <a:schemeClr val="tx2"/>
+                </a:solidFill>
+                <a:latin typeface="Source Sans Pro Light" panose="020B0403030403020204" pitchFamily="34" charset="77"/>
+                <a:ea typeface="Source Sans Pro" panose="020B0503030403020204" pitchFamily="34" charset="0"/>
+              </a:rPr>
+              <a:t>&amp; Swap</a:t>
             </a:r>
           </a:p>
         </p:txBody>

</xml_diff>